<commit_message>
feat: fill SentinelAI team details, add team-profile PDF
Real member details (Saatwik Sairaam Vasamsetti, Sai Nirisha Chowdary
Pavuluri — Integrated M.Tech CSE, VIT-AP, batch 2024-29) and contact emails
across deck, TEAM.md and new SentinelAI_Team_Profiles.pdf. Only the demo
video link placeholder remains.
</commit_message>
<xml_diff>
--- a/sentinelai/SentinelAI_Execution_Plan.pptx
+++ b/sentinelai/SentinelAI_Execution_Plan.pptx
@@ -1140,7 +1140,7 @@
           <a:p>
             <a:r>
               <a:rPr lang="en-US" dirty="0"/>
-              <a:t>Two co-founders with complementary ownership: Saatwik on engineering (edge AI, dashboard), Nirisha on research and strategy (validation, business model, IP). Bracketed placeholders — degree/college and confirmed advisor names — must be filled before submission.</a:t>
+              <a:t>Two co-founders, both Integrated M.Tech CSE at VIT-AP University (batch 2024-29), with complementary ownership: Saatwik on engineering (edge AI, dashboard), Nirisha on research and strategy (validation, business model, IP). Advisor slots are outreach targets for Phase 1.</a:t>
             </a:r>
             <a:endParaRPr lang="en-US" dirty="0"/>
           </a:p>
@@ -2995,8 +2995,8 @@
         </p:nvSpPr>
         <p:spPr>
           <a:xfrm>
-            <a:off x="1371600" y="5349240"/>
-            <a:ext cx="9445752" cy="320040"/>
+            <a:off x="1371600" y="5303520"/>
+            <a:ext cx="9445752" cy="594360"/>
           </a:xfrm>
           <a:prstGeom prst="rect">
             <a:avLst/>
@@ -3014,13 +3014,28 @@
             <a:r>
               <a:rPr lang="en-US" sz="1300" dirty="0">
                 <a:solidFill>
+                  <a:srgbClr val="A8C6E8"/>
+                </a:solidFill>
+                <a:latin typeface="Calibri" pitchFamily="34" charset="0"/>
+                <a:ea typeface="Calibri" pitchFamily="34" charset="-122"/>
+                <a:cs typeface="Calibri" pitchFamily="34" charset="-120"/>
+              </a:rPr>
+              <a:t>Saatwik Sairaam Vasamsetti  •  Sai Nirisha Chowdary Pavuluri
+</a:t>
+            </a:r>
+            <a:pPr algn="ctr" indent="0" marL="0">
+              <a:buNone/>
+            </a:pPr>
+            <a:r>
+              <a:rPr lang="en-US" sz="1300" dirty="0">
+                <a:solidFill>
                   <a:srgbClr val="7E97B8"/>
                 </a:solidFill>
                 <a:latin typeface="Calibri" pitchFamily="34" charset="0"/>
                 <a:ea typeface="Calibri" pitchFamily="34" charset="-122"/>
                 <a:cs typeface="Calibri" pitchFamily="34" charset="-120"/>
               </a:rPr>
-              <a:t>Saatwik  •  Nirisha Chowdary          July 2026</a:t>
+              <a:t>VIT-AP University  ·  July 2026</a:t>
             </a:r>
             <a:endParaRPr lang="en-US" sz="1300" dirty="0"/>
           </a:p>
@@ -7294,8 +7309,8 @@
         </p:nvSpPr>
         <p:spPr>
           <a:xfrm>
-            <a:off x="1965960" y="2011680"/>
-            <a:ext cx="3840480" cy="411480"/>
+            <a:off x="1965960" y="2029968"/>
+            <a:ext cx="3886200" cy="411480"/>
           </a:xfrm>
           <a:prstGeom prst="rect">
             <a:avLst/>
@@ -7311,7 +7326,7 @@
               <a:buNone/>
             </a:pPr>
             <a:r>
-              <a:rPr lang="en-US" sz="2000" b="1" dirty="0">
+              <a:rPr lang="en-US" sz="1650" b="1" dirty="0">
                 <a:solidFill>
                   <a:srgbClr val="FFFFFF"/>
                 </a:solidFill>
@@ -7319,9 +7334,9 @@
                 <a:ea typeface="Calibri" pitchFamily="34" charset="-122"/>
                 <a:cs typeface="Calibri" pitchFamily="34" charset="-120"/>
               </a:rPr>
-              <a:t>Saatwik</a:t>
-            </a:r>
-            <a:endParaRPr lang="en-US" sz="2000" dirty="0"/>
+              <a:t>Saatwik Sairaam Vasamsetti</a:t>
+            </a:r>
+            <a:endParaRPr lang="en-US" sz="1650" dirty="0"/>
           </a:p>
         </p:txBody>
       </p:sp>
@@ -7401,7 +7416,7 @@
                 <a:ea typeface="Calibri" pitchFamily="34" charset="-122"/>
                 <a:cs typeface="Calibri" pitchFamily="34" charset="-120"/>
               </a:rPr>
-              <a:t>Full-stack developer — shipped PathAhead (career-guidance platform), an ML stock-prediction system, and multiple production web platforms</a:t>
+              <a:t>Integrated M.Tech, CSE (5-year) — VIT-AP University, Batch 2024–29</a:t>
             </a:r>
             <a:endParaRPr lang="en-US" sz="1100" dirty="0"/>
           </a:p>
@@ -7422,7 +7437,7 @@
                 <a:ea typeface="Calibri" pitchFamily="34" charset="-122"/>
                 <a:cs typeface="Calibri" pitchFamily="34" charset="-120"/>
               </a:rPr>
-              <a:t>Owns: edge AI models, sensor fusion, dashboard build</a:t>
+              <a:t>Full-stack developer — shipped PathAhead (career-guidance platform), an ML stock-prediction system, and multiple production web platforms</a:t>
             </a:r>
             <a:endParaRPr lang="en-US" sz="1100" dirty="0"/>
           </a:p>
@@ -7443,7 +7458,7 @@
                 <a:ea typeface="Calibri" pitchFamily="34" charset="-122"/>
                 <a:cs typeface="Calibri" pitchFamily="34" charset="-120"/>
               </a:rPr>
-              <a:t>[Add: degree, branch, college, year]</a:t>
+              <a:t>Owns: edge AI models, sensor fusion, dashboard build</a:t>
             </a:r>
             <a:endParaRPr lang="en-US" sz="1100" dirty="0"/>
           </a:p>
@@ -7529,7 +7544,7 @@
                 <a:ea typeface="Calibri" pitchFamily="34" charset="-122"/>
                 <a:cs typeface="Calibri" pitchFamily="34" charset="-120"/>
               </a:rPr>
-              <a:t>N</a:t>
+              <a:t>S</a:t>
             </a:r>
             <a:endParaRPr lang="en-US" sz="3000" dirty="0"/>
           </a:p>
@@ -7543,8 +7558,8 @@
         </p:nvSpPr>
         <p:spPr>
           <a:xfrm>
-            <a:off x="7589520" y="2011680"/>
-            <a:ext cx="3840480" cy="411480"/>
+            <a:off x="7589520" y="2029968"/>
+            <a:ext cx="3886200" cy="411480"/>
           </a:xfrm>
           <a:prstGeom prst="rect">
             <a:avLst/>
@@ -7560,7 +7575,7 @@
               <a:buNone/>
             </a:pPr>
             <a:r>
-              <a:rPr lang="en-US" sz="2000" b="1" dirty="0">
+              <a:rPr lang="en-US" sz="1650" b="1" dirty="0">
                 <a:solidFill>
                   <a:srgbClr val="FFFFFF"/>
                 </a:solidFill>
@@ -7568,9 +7583,9 @@
                 <a:ea typeface="Calibri" pitchFamily="34" charset="-122"/>
                 <a:cs typeface="Calibri" pitchFamily="34" charset="-120"/>
               </a:rPr>
-              <a:t>Nirisha Chowdary</a:t>
-            </a:r>
-            <a:endParaRPr lang="en-US" sz="2000" dirty="0"/>
+              <a:t>Sai Nirisha Chowdary Pavuluri</a:t>
+            </a:r>
+            <a:endParaRPr lang="en-US" sz="1650" dirty="0"/>
           </a:p>
         </p:txBody>
       </p:sp>
@@ -7650,7 +7665,7 @@
                 <a:ea typeface="Calibri" pitchFamily="34" charset="-122"/>
                 <a:cs typeface="Calibri" pitchFamily="34" charset="-120"/>
               </a:rPr>
-              <a:t>Concept originator — authored the SentinelAI vision, market analysis and IP strategy; built a GPT implementation from scratch in pure Python</a:t>
+              <a:t>Integrated M.Tech, CSE (5-year) — VIT-AP University, Batch 2024–29</a:t>
             </a:r>
             <a:endParaRPr lang="en-US" sz="1100" dirty="0"/>
           </a:p>
@@ -7671,7 +7686,7 @@
                 <a:ea typeface="Calibri" pitchFamily="34" charset="-122"/>
                 <a:cs typeface="Calibri" pitchFamily="34" charset="-120"/>
               </a:rPr>
-              <a:t>Owns: stakeholder validation, business model, partnerships</a:t>
+              <a:t>Concept originator — authored the SentinelAI vision, market analysis and IP strategy; built a GPT implementation from scratch in pure Python</a:t>
             </a:r>
             <a:endParaRPr lang="en-US" sz="1100" dirty="0"/>
           </a:p>
@@ -7692,7 +7707,7 @@
                 <a:ea typeface="Calibri" pitchFamily="34" charset="-122"/>
                 <a:cs typeface="Calibri" pitchFamily="34" charset="-120"/>
               </a:rPr>
-              <a:t>[Add: degree, branch, college, year]</a:t>
+              <a:t>Owns: stakeholder validation, business model, partnerships</a:t>
             </a:r>
             <a:endParaRPr lang="en-US" sz="1100" dirty="0"/>
           </a:p>
@@ -7792,7 +7807,7 @@
                 <a:ea typeface="Calibri" pitchFamily="34" charset="-122"/>
                 <a:cs typeface="Calibri" pitchFamily="34" charset="-120"/>
               </a:rPr>
-              <a:t>Phase 1 targets: one police-department mentor, one 108/EMRI operations contact, one municipal smart-city officer, one faculty advisor (embedded systems / AI). [Add names as confirmed]</a:t>
+              <a:t>Phase 1 targets: one police-department mentor, one 108/EMRI operations contact, one municipal smart-city officer, one faculty advisor (embedded systems / AI) at VIT-AP. Names added as they are confirmed.</a:t>
             </a:r>
             <a:endParaRPr lang="en-US" sz="1200" dirty="0"/>
           </a:p>
@@ -9632,8 +9647,8 @@
         </p:nvSpPr>
         <p:spPr>
           <a:xfrm>
-            <a:off x="1097280" y="5532120"/>
-            <a:ext cx="9994392" cy="320040"/>
+            <a:off x="1097280" y="5440680"/>
+            <a:ext cx="9994392" cy="594360"/>
           </a:xfrm>
           <a:prstGeom prst="rect">
             <a:avLst/>
@@ -9651,13 +9666,28 @@
             <a:r>
               <a:rPr lang="en-US" sz="1250" dirty="0">
                 <a:solidFill>
+                  <a:srgbClr val="A8C6E8"/>
+                </a:solidFill>
+                <a:latin typeface="Calibri" pitchFamily="34" charset="0"/>
+                <a:ea typeface="Calibri" pitchFamily="34" charset="-122"/>
+                <a:cs typeface="Calibri" pitchFamily="34" charset="-120"/>
+              </a:rPr>
+              <a:t>Team SentinelAI — VIT-AP University
+</a:t>
+            </a:r>
+            <a:pPr algn="ctr" indent="0" marL="0">
+              <a:buNone/>
+            </a:pPr>
+            <a:r>
+              <a:rPr lang="en-US" sz="1250" dirty="0">
+                <a:solidFill>
                   <a:srgbClr val="7E97B8"/>
                 </a:solidFill>
                 <a:latin typeface="Calibri" pitchFamily="34" charset="0"/>
                 <a:ea typeface="Calibri" pitchFamily="34" charset="-122"/>
                 <a:cs typeface="Calibri" pitchFamily="34" charset="-120"/>
               </a:rPr>
-              <a:t>Team SentinelAI  •  adithya001v@gmail.com</a:t>
+              <a:t>saathwik.13@gmail.com  •  nirishapavuluri@gmail.com</a:t>
             </a:r>
             <a:endParaRPr lang="en-US" sz="1250" dirty="0"/>
           </a:p>

</xml_diff>

<commit_message>
feat: add GitHub + LinkedIn profiles across the SentinelAI package
Team slide gets clickable GitHub/LinkedIn chips per founder, closing slide
gets a profile link row, TEAM.md and the team-profile PDF list both profiles
(plus Saatwik's portfolio), and the demo end card credits both founders with
their handles — so the video itself carries them.

Profiles sourced from the owners' own portfolios/resumes:
saatwik-1157 + saatwiksairaamvasamsetti, Nirisha22 + nirisha-chowdary.

Also: fix pptxgenjs hyperlink corruption (hyperlink must be per text run, not
on the outer options, else it emits rIdundefined) and correct the video frame
timing floor that was pacing the capture ~12% slow; video is now real-time
63.6 s and trimmed to the end card.
</commit_message>
<xml_diff>
--- a/sentinelai/SentinelAI_Execution_Plan.pptx
+++ b/sentinelai/SentinelAI_Execution_Plan.pptx
@@ -7224,11 +7224,11 @@
         <p:spPr>
           <a:xfrm>
             <a:off x="548640" y="1600200"/>
-            <a:ext cx="5468112" cy="3291840"/>
+            <a:ext cx="5468112" cy="3429000"/>
           </a:xfrm>
           <a:prstGeom prst="roundRect">
             <a:avLst>
-              <a:gd name="adj" fmla="val 2222"/>
+              <a:gd name="adj" fmla="val 2133"/>
             </a:avLst>
           </a:prstGeom>
           <a:solidFill>
@@ -7387,8 +7387,8 @@
         </p:nvSpPr>
         <p:spPr>
           <a:xfrm>
-            <a:off x="914400" y="3063240"/>
-            <a:ext cx="4800600" cy="1737360"/>
+            <a:off x="914400" y="3017520"/>
+            <a:ext cx="4800600" cy="1371600"/>
           </a:xfrm>
           <a:prstGeom prst="rect">
             <a:avLst/>
@@ -7472,15 +7472,193 @@
         </p:nvSpPr>
         <p:spPr>
           <a:xfrm>
-            <a:off x="6172200" y="1600200"/>
-            <a:ext cx="5468112" cy="3291840"/>
+            <a:off x="914400" y="4462272"/>
+            <a:ext cx="2432304" cy="420624"/>
           </a:xfrm>
           <a:prstGeom prst="roundRect">
             <a:avLst>
-              <a:gd name="adj" fmla="val 2222"/>
+              <a:gd name="adj" fmla="val 15217"/>
             </a:avLst>
           </a:prstGeom>
           <a:solidFill>
+            <a:srgbClr val="1B3155"/>
+          </a:solidFill>
+          <a:ln/>
+        </p:spPr>
+      </p:sp>
+      <p:sp>
+        <p:nvSpPr>
+          <p:cNvPr id="15" name="Text 13"/>
+          <p:cNvSpPr/>
+          <p:nvPr/>
+        </p:nvSpPr>
+        <p:spPr>
+          <a:xfrm>
+            <a:off x="1024128" y="4462272"/>
+            <a:ext cx="2212848" cy="420624"/>
+          </a:xfrm>
+          <a:prstGeom prst="rect">
+            <a:avLst/>
+          </a:prstGeom>
+          <a:noFill/>
+          <a:ln/>
+        </p:spPr>
+        <p:txBody>
+          <a:bodyPr wrap="square" lIns="0" tIns="0" rIns="0" bIns="0" rtlCol="0" anchor="ctr"/>
+          <a:lstStyle/>
+          <a:p>
+            <a:pPr indent="0" marL="0">
+              <a:buNone/>
+            </a:pPr>
+            <a:r>
+              <a:rPr lang="en-US" sz="1000" b="1" u="sng" dirty="0">
+                <a:solidFill>
+                  <a:srgbClr val="FFB300"/>
+                </a:solidFill>
+                <a:latin typeface="Calibri" pitchFamily="34" charset="0"/>
+                <a:ea typeface="Calibri" pitchFamily="34" charset="-122"/>
+                <a:cs typeface="Calibri" pitchFamily="34" charset="-120"/>
+                <a:hlinkClick r:id="rId1" invalidUrl="" action="" tgtFrame="" tooltip="" history="1" highlightClick="0" endSnd="0">
+                  <a:extLst>
+                    <a:ext uri="{A12FA001-AC4F-418D-AE19-62706E023703}">
+                      <ahyp:hlinkClr xmlns:ahyp="http://schemas.microsoft.com/office/drawing/2018/hyperlinkcolor" val="tx"/>
+                    </a:ext>
+                  </a:extLst>
+                </a:hlinkClick>
+              </a:rPr>
+              <a:t>GitHub  </a:t>
+            </a:r>
+            <a:pPr indent="0" marL="0">
+              <a:buNone/>
+            </a:pPr>
+            <a:r>
+              <a:rPr lang="en-US" sz="1000" u="sng" dirty="0">
+                <a:solidFill>
+                  <a:srgbClr val="FFFFFF"/>
+                </a:solidFill>
+                <a:latin typeface="Calibri" pitchFamily="34" charset="0"/>
+                <a:ea typeface="Calibri" pitchFamily="34" charset="-122"/>
+                <a:cs typeface="Calibri" pitchFamily="34" charset="-120"/>
+                <a:hlinkClick r:id="rId2" invalidUrl="" action="" tgtFrame="" tooltip="" history="1" highlightClick="0" endSnd="0">
+                  <a:extLst>
+                    <a:ext uri="{A12FA001-AC4F-418D-AE19-62706E023703}">
+                      <ahyp:hlinkClr xmlns:ahyp="http://schemas.microsoft.com/office/drawing/2018/hyperlinkcolor" val="tx"/>
+                    </a:ext>
+                  </a:extLst>
+                </a:hlinkClick>
+              </a:rPr>
+              <a:t>/saatwik-1157</a:t>
+            </a:r>
+            <a:endParaRPr lang="en-US" sz="1000" dirty="0"/>
+          </a:p>
+        </p:txBody>
+      </p:sp>
+      <p:sp>
+        <p:nvSpPr>
+          <p:cNvPr id="16" name="Shape 14"/>
+          <p:cNvSpPr/>
+          <p:nvPr/>
+        </p:nvSpPr>
+        <p:spPr>
+          <a:xfrm>
+            <a:off x="3493008" y="4462272"/>
+            <a:ext cx="2432304" cy="420624"/>
+          </a:xfrm>
+          <a:prstGeom prst="roundRect">
+            <a:avLst>
+              <a:gd name="adj" fmla="val 15217"/>
+            </a:avLst>
+          </a:prstGeom>
+          <a:solidFill>
+            <a:srgbClr val="1B3155"/>
+          </a:solidFill>
+          <a:ln/>
+        </p:spPr>
+      </p:sp>
+      <p:sp>
+        <p:nvSpPr>
+          <p:cNvPr id="17" name="Text 15"/>
+          <p:cNvSpPr/>
+          <p:nvPr/>
+        </p:nvSpPr>
+        <p:spPr>
+          <a:xfrm>
+            <a:off x="3602736" y="4462272"/>
+            <a:ext cx="2212848" cy="420624"/>
+          </a:xfrm>
+          <a:prstGeom prst="rect">
+            <a:avLst/>
+          </a:prstGeom>
+          <a:noFill/>
+          <a:ln/>
+        </p:spPr>
+        <p:txBody>
+          <a:bodyPr wrap="square" lIns="0" tIns="0" rIns="0" bIns="0" rtlCol="0" anchor="ctr"/>
+          <a:lstStyle/>
+          <a:p>
+            <a:pPr indent="0" marL="0">
+              <a:buNone/>
+            </a:pPr>
+            <a:r>
+              <a:rPr lang="en-US" sz="1000" b="1" u="sng" dirty="0">
+                <a:solidFill>
+                  <a:srgbClr val="FFB300"/>
+                </a:solidFill>
+                <a:latin typeface="Calibri" pitchFamily="34" charset="0"/>
+                <a:ea typeface="Calibri" pitchFamily="34" charset="-122"/>
+                <a:cs typeface="Calibri" pitchFamily="34" charset="-120"/>
+                <a:hlinkClick r:id="rId3" invalidUrl="" action="" tgtFrame="" tooltip="" history="1" highlightClick="0" endSnd="0">
+                  <a:extLst>
+                    <a:ext uri="{A12FA001-AC4F-418D-AE19-62706E023703}">
+                      <ahyp:hlinkClr xmlns:ahyp="http://schemas.microsoft.com/office/drawing/2018/hyperlinkcolor" val="tx"/>
+                    </a:ext>
+                  </a:extLst>
+                </a:hlinkClick>
+              </a:rPr>
+              <a:t>LinkedIn  </a:t>
+            </a:r>
+            <a:pPr indent="0" marL="0">
+              <a:buNone/>
+            </a:pPr>
+            <a:r>
+              <a:rPr lang="en-US" sz="1000" u="sng" dirty="0">
+                <a:solidFill>
+                  <a:srgbClr val="FFFFFF"/>
+                </a:solidFill>
+                <a:latin typeface="Calibri" pitchFamily="34" charset="0"/>
+                <a:ea typeface="Calibri" pitchFamily="34" charset="-122"/>
+                <a:cs typeface="Calibri" pitchFamily="34" charset="-120"/>
+                <a:hlinkClick r:id="rId4" invalidUrl="" action="" tgtFrame="" tooltip="" history="1" highlightClick="0" endSnd="0">
+                  <a:extLst>
+                    <a:ext uri="{A12FA001-AC4F-418D-AE19-62706E023703}">
+                      <ahyp:hlinkClr xmlns:ahyp="http://schemas.microsoft.com/office/drawing/2018/hyperlinkcolor" val="tx"/>
+                    </a:ext>
+                  </a:extLst>
+                </a:hlinkClick>
+              </a:rPr>
+              <a:t>/saatwiksairaamvasamsetti</a:t>
+            </a:r>
+            <a:endParaRPr lang="en-US" sz="1000" dirty="0"/>
+          </a:p>
+        </p:txBody>
+      </p:sp>
+      <p:sp>
+        <p:nvSpPr>
+          <p:cNvPr id="18" name="Shape 16"/>
+          <p:cNvSpPr/>
+          <p:nvPr/>
+        </p:nvSpPr>
+        <p:spPr>
+          <a:xfrm>
+            <a:off x="6172200" y="1600200"/>
+            <a:ext cx="5468112" cy="3429000"/>
+          </a:xfrm>
+          <a:prstGeom prst="roundRect">
+            <a:avLst>
+              <a:gd name="adj" fmla="val 2133"/>
+            </a:avLst>
+          </a:prstGeom>
+          <a:solidFill>
             <a:srgbClr val="16294A"/>
           </a:solidFill>
           <a:ln/>
@@ -7488,7 +7666,7 @@
       </p:sp>
       <p:sp>
         <p:nvSpPr>
-          <p:cNvPr id="15" name="Shape 13"/>
+          <p:cNvPr id="19" name="Shape 17"/>
           <p:cNvSpPr/>
           <p:nvPr/>
         </p:nvSpPr>
@@ -7513,7 +7691,7 @@
       </p:sp>
       <p:sp>
         <p:nvSpPr>
-          <p:cNvPr id="16" name="Text 14"/>
+          <p:cNvPr id="20" name="Text 18"/>
           <p:cNvSpPr/>
           <p:nvPr/>
         </p:nvSpPr>
@@ -7552,7 +7730,7 @@
       </p:sp>
       <p:sp>
         <p:nvSpPr>
-          <p:cNvPr id="17" name="Text 15"/>
+          <p:cNvPr id="21" name="Text 19"/>
           <p:cNvSpPr/>
           <p:nvPr/>
         </p:nvSpPr>
@@ -7591,7 +7769,7 @@
       </p:sp>
       <p:sp>
         <p:nvSpPr>
-          <p:cNvPr id="18" name="Text 16"/>
+          <p:cNvPr id="22" name="Text 20"/>
           <p:cNvSpPr/>
           <p:nvPr/>
         </p:nvSpPr>
@@ -7630,14 +7808,14 @@
       </p:sp>
       <p:sp>
         <p:nvSpPr>
-          <p:cNvPr id="19" name="Text 17"/>
-          <p:cNvSpPr/>
-          <p:nvPr/>
-        </p:nvSpPr>
-        <p:spPr>
-          <a:xfrm>
-            <a:off x="6537960" y="3063240"/>
-            <a:ext cx="4800600" cy="1737360"/>
+          <p:cNvPr id="23" name="Text 21"/>
+          <p:cNvSpPr/>
+          <p:nvPr/>
+        </p:nvSpPr>
+        <p:spPr>
+          <a:xfrm>
+            <a:off x="6537960" y="3017520"/>
+            <a:ext cx="4800600" cy="1371600"/>
           </a:xfrm>
           <a:prstGeom prst="rect">
             <a:avLst/>
@@ -7715,18 +7893,18 @@
       </p:sp>
       <p:sp>
         <p:nvSpPr>
-          <p:cNvPr id="20" name="Shape 18"/>
-          <p:cNvSpPr/>
-          <p:nvPr/>
-        </p:nvSpPr>
-        <p:spPr>
-          <a:xfrm>
-            <a:off x="548640" y="5120640"/>
-            <a:ext cx="11091672" cy="1143000"/>
+          <p:cNvPr id="24" name="Shape 22"/>
+          <p:cNvSpPr/>
+          <p:nvPr/>
+        </p:nvSpPr>
+        <p:spPr>
+          <a:xfrm>
+            <a:off x="6537960" y="4462272"/>
+            <a:ext cx="2432304" cy="420624"/>
           </a:xfrm>
           <a:prstGeom prst="roundRect">
             <a:avLst>
-              <a:gd name="adj" fmla="val 6400"/>
+              <a:gd name="adj" fmla="val 15217"/>
             </a:avLst>
           </a:prstGeom>
           <a:solidFill>
@@ -7737,13 +7915,191 @@
       </p:sp>
       <p:sp>
         <p:nvSpPr>
-          <p:cNvPr id="21" name="Text 19"/>
-          <p:cNvSpPr/>
-          <p:nvPr/>
-        </p:nvSpPr>
-        <p:spPr>
-          <a:xfrm>
-            <a:off x="868680" y="5303520"/>
+          <p:cNvPr id="25" name="Text 23"/>
+          <p:cNvSpPr/>
+          <p:nvPr/>
+        </p:nvSpPr>
+        <p:spPr>
+          <a:xfrm>
+            <a:off x="6647688" y="4462272"/>
+            <a:ext cx="2212848" cy="420624"/>
+          </a:xfrm>
+          <a:prstGeom prst="rect">
+            <a:avLst/>
+          </a:prstGeom>
+          <a:noFill/>
+          <a:ln/>
+        </p:spPr>
+        <p:txBody>
+          <a:bodyPr wrap="square" lIns="0" tIns="0" rIns="0" bIns="0" rtlCol="0" anchor="ctr"/>
+          <a:lstStyle/>
+          <a:p>
+            <a:pPr indent="0" marL="0">
+              <a:buNone/>
+            </a:pPr>
+            <a:r>
+              <a:rPr lang="en-US" sz="1000" b="1" u="sng" dirty="0">
+                <a:solidFill>
+                  <a:srgbClr val="FFB300"/>
+                </a:solidFill>
+                <a:latin typeface="Calibri" pitchFamily="34" charset="0"/>
+                <a:ea typeface="Calibri" pitchFamily="34" charset="-122"/>
+                <a:cs typeface="Calibri" pitchFamily="34" charset="-120"/>
+                <a:hlinkClick r:id="rId5" invalidUrl="" action="" tgtFrame="" tooltip="" history="1" highlightClick="0" endSnd="0">
+                  <a:extLst>
+                    <a:ext uri="{A12FA001-AC4F-418D-AE19-62706E023703}">
+                      <ahyp:hlinkClr xmlns:ahyp="http://schemas.microsoft.com/office/drawing/2018/hyperlinkcolor" val="tx"/>
+                    </a:ext>
+                  </a:extLst>
+                </a:hlinkClick>
+              </a:rPr>
+              <a:t>GitHub  </a:t>
+            </a:r>
+            <a:pPr indent="0" marL="0">
+              <a:buNone/>
+            </a:pPr>
+            <a:r>
+              <a:rPr lang="en-US" sz="1000" u="sng" dirty="0">
+                <a:solidFill>
+                  <a:srgbClr val="FFFFFF"/>
+                </a:solidFill>
+                <a:latin typeface="Calibri" pitchFamily="34" charset="0"/>
+                <a:ea typeface="Calibri" pitchFamily="34" charset="-122"/>
+                <a:cs typeface="Calibri" pitchFamily="34" charset="-120"/>
+                <a:hlinkClick r:id="rId6" invalidUrl="" action="" tgtFrame="" tooltip="" history="1" highlightClick="0" endSnd="0">
+                  <a:extLst>
+                    <a:ext uri="{A12FA001-AC4F-418D-AE19-62706E023703}">
+                      <ahyp:hlinkClr xmlns:ahyp="http://schemas.microsoft.com/office/drawing/2018/hyperlinkcolor" val="tx"/>
+                    </a:ext>
+                  </a:extLst>
+                </a:hlinkClick>
+              </a:rPr>
+              <a:t>/Nirisha22</a:t>
+            </a:r>
+            <a:endParaRPr lang="en-US" sz="1000" dirty="0"/>
+          </a:p>
+        </p:txBody>
+      </p:sp>
+      <p:sp>
+        <p:nvSpPr>
+          <p:cNvPr id="26" name="Shape 24"/>
+          <p:cNvSpPr/>
+          <p:nvPr/>
+        </p:nvSpPr>
+        <p:spPr>
+          <a:xfrm>
+            <a:off x="9116568" y="4462272"/>
+            <a:ext cx="2432304" cy="420624"/>
+          </a:xfrm>
+          <a:prstGeom prst="roundRect">
+            <a:avLst>
+              <a:gd name="adj" fmla="val 15217"/>
+            </a:avLst>
+          </a:prstGeom>
+          <a:solidFill>
+            <a:srgbClr val="1B3155"/>
+          </a:solidFill>
+          <a:ln/>
+        </p:spPr>
+      </p:sp>
+      <p:sp>
+        <p:nvSpPr>
+          <p:cNvPr id="27" name="Text 25"/>
+          <p:cNvSpPr/>
+          <p:nvPr/>
+        </p:nvSpPr>
+        <p:spPr>
+          <a:xfrm>
+            <a:off x="9226296" y="4462272"/>
+            <a:ext cx="2212848" cy="420624"/>
+          </a:xfrm>
+          <a:prstGeom prst="rect">
+            <a:avLst/>
+          </a:prstGeom>
+          <a:noFill/>
+          <a:ln/>
+        </p:spPr>
+        <p:txBody>
+          <a:bodyPr wrap="square" lIns="0" tIns="0" rIns="0" bIns="0" rtlCol="0" anchor="ctr"/>
+          <a:lstStyle/>
+          <a:p>
+            <a:pPr indent="0" marL="0">
+              <a:buNone/>
+            </a:pPr>
+            <a:r>
+              <a:rPr lang="en-US" sz="1000" b="1" u="sng" dirty="0">
+                <a:solidFill>
+                  <a:srgbClr val="FFB300"/>
+                </a:solidFill>
+                <a:latin typeface="Calibri" pitchFamily="34" charset="0"/>
+                <a:ea typeface="Calibri" pitchFamily="34" charset="-122"/>
+                <a:cs typeface="Calibri" pitchFamily="34" charset="-120"/>
+                <a:hlinkClick r:id="rId7" invalidUrl="" action="" tgtFrame="" tooltip="" history="1" highlightClick="0" endSnd="0">
+                  <a:extLst>
+                    <a:ext uri="{A12FA001-AC4F-418D-AE19-62706E023703}">
+                      <ahyp:hlinkClr xmlns:ahyp="http://schemas.microsoft.com/office/drawing/2018/hyperlinkcolor" val="tx"/>
+                    </a:ext>
+                  </a:extLst>
+                </a:hlinkClick>
+              </a:rPr>
+              <a:t>LinkedIn  </a:t>
+            </a:r>
+            <a:pPr indent="0" marL="0">
+              <a:buNone/>
+            </a:pPr>
+            <a:r>
+              <a:rPr lang="en-US" sz="1000" u="sng" dirty="0">
+                <a:solidFill>
+                  <a:srgbClr val="FFFFFF"/>
+                </a:solidFill>
+                <a:latin typeface="Calibri" pitchFamily="34" charset="0"/>
+                <a:ea typeface="Calibri" pitchFamily="34" charset="-122"/>
+                <a:cs typeface="Calibri" pitchFamily="34" charset="-120"/>
+                <a:hlinkClick r:id="rId8" invalidUrl="" action="" tgtFrame="" tooltip="" history="1" highlightClick="0" endSnd="0">
+                  <a:extLst>
+                    <a:ext uri="{A12FA001-AC4F-418D-AE19-62706E023703}">
+                      <ahyp:hlinkClr xmlns:ahyp="http://schemas.microsoft.com/office/drawing/2018/hyperlinkcolor" val="tx"/>
+                    </a:ext>
+                  </a:extLst>
+                </a:hlinkClick>
+              </a:rPr>
+              <a:t>/nirisha-chowdary</a:t>
+            </a:r>
+            <a:endParaRPr lang="en-US" sz="1000" dirty="0"/>
+          </a:p>
+        </p:txBody>
+      </p:sp>
+      <p:sp>
+        <p:nvSpPr>
+          <p:cNvPr id="28" name="Shape 26"/>
+          <p:cNvSpPr/>
+          <p:nvPr/>
+        </p:nvSpPr>
+        <p:spPr>
+          <a:xfrm>
+            <a:off x="548640" y="5230368"/>
+            <a:ext cx="11091672" cy="1033272"/>
+          </a:xfrm>
+          <a:prstGeom prst="roundRect">
+            <a:avLst>
+              <a:gd name="adj" fmla="val 7080"/>
+            </a:avLst>
+          </a:prstGeom>
+          <a:solidFill>
+            <a:srgbClr val="1B3155"/>
+          </a:solidFill>
+          <a:ln/>
+        </p:spPr>
+      </p:sp>
+      <p:sp>
+        <p:nvSpPr>
+          <p:cNvPr id="29" name="Text 27"/>
+          <p:cNvSpPr/>
+          <p:nvPr/>
+        </p:nvSpPr>
+        <p:spPr>
+          <a:xfrm>
+            <a:off x="868680" y="5358384"/>
             <a:ext cx="10424160" cy="274320"/>
           </a:xfrm>
           <a:prstGeom prst="rect">
@@ -7776,14 +8132,14 @@
       </p:sp>
       <p:sp>
         <p:nvSpPr>
-          <p:cNvPr id="22" name="Text 20"/>
-          <p:cNvSpPr/>
-          <p:nvPr/>
-        </p:nvSpPr>
-        <p:spPr>
-          <a:xfrm>
-            <a:off x="868680" y="5623560"/>
-            <a:ext cx="10424160" cy="548640"/>
+          <p:cNvPr id="30" name="Text 28"/>
+          <p:cNvSpPr/>
+          <p:nvPr/>
+        </p:nvSpPr>
+        <p:spPr>
+          <a:xfrm>
+            <a:off x="868680" y="5650992"/>
+            <a:ext cx="10424160" cy="502920"/>
           </a:xfrm>
           <a:prstGeom prst="rect">
             <a:avLst/>
@@ -9647,8 +10003,8 @@
         </p:nvSpPr>
         <p:spPr>
           <a:xfrm>
-            <a:off x="1097280" y="5440680"/>
-            <a:ext cx="9994392" cy="594360"/>
+            <a:off x="1097280" y="5394960"/>
+            <a:ext cx="9994392" cy="548640"/>
           </a:xfrm>
           <a:prstGeom prst="rect">
             <a:avLst/>
@@ -9690,6 +10046,315 @@
               <a:t>saathwik.13@gmail.com  •  nirishapavuluri@gmail.com</a:t>
             </a:r>
             <a:endParaRPr lang="en-US" sz="1250" dirty="0"/>
+          </a:p>
+        </p:txBody>
+      </p:sp>
+      <p:sp>
+        <p:nvSpPr>
+          <p:cNvPr id="30" name="Text 28">
+            <a:hlinkClick r:id="rId1" tooltip=""/>
+          </p:cNvPr>
+          <p:cNvSpPr/>
+          <p:nvPr/>
+        </p:nvSpPr>
+        <p:spPr>
+          <a:xfrm>
+            <a:off x="1097280" y="5943600"/>
+            <a:ext cx="2148840" cy="292608"/>
+          </a:xfrm>
+          <a:prstGeom prst="rect">
+            <a:avLst/>
+          </a:prstGeom>
+          <a:noFill/>
+          <a:ln/>
+        </p:spPr>
+        <p:txBody>
+          <a:bodyPr wrap="square" lIns="0" tIns="0" rIns="0" bIns="0" rtlCol="0" anchor="ctr"/>
+          <a:lstStyle/>
+          <a:p>
+            <a:pPr algn="ctr" indent="0" marL="0">
+              <a:buNone/>
+            </a:pPr>
+            <a:r>
+              <a:rPr lang="en-US" sz="1000" u="sng" dirty="0">
+                <a:solidFill>
+                  <a:srgbClr val="A8C6E8"/>
+                </a:solidFill>
+                <a:latin typeface="Calibri" pitchFamily="34" charset="0"/>
+                <a:ea typeface="Calibri" pitchFamily="34" charset="-122"/>
+                <a:cs typeface="Calibri" pitchFamily="34" charset="-120"/>
+                <a:hlinkClick r:id="rId1" invalidUrl="" action="" tgtFrame="" tooltip="" history="1" highlightClick="0" endSnd="0">
+                  <a:extLst>
+                    <a:ext uri="{A12FA001-AC4F-418D-AE19-62706E023703}">
+                      <ahyp:hlinkClr xmlns:ahyp="http://schemas.microsoft.com/office/drawing/2018/hyperlinkcolor" val="tx"/>
+                    </a:ext>
+                  </a:extLst>
+                </a:hlinkClick>
+              </a:rPr>
+              <a:t>github.com/saatwik-1157</a:t>
+            </a:r>
+            <a:endParaRPr lang="en-US" sz="1000" dirty="0"/>
+          </a:p>
+        </p:txBody>
+      </p:sp>
+      <p:sp>
+        <p:nvSpPr>
+          <p:cNvPr id="31" name="Text 29"/>
+          <p:cNvSpPr/>
+          <p:nvPr/>
+        </p:nvSpPr>
+        <p:spPr>
+          <a:xfrm>
+            <a:off x="3246120" y="5943600"/>
+            <a:ext cx="128016" cy="292608"/>
+          </a:xfrm>
+          <a:prstGeom prst="rect">
+            <a:avLst/>
+          </a:prstGeom>
+          <a:noFill/>
+          <a:ln/>
+        </p:spPr>
+        <p:txBody>
+          <a:bodyPr wrap="square" lIns="0" tIns="0" rIns="0" bIns="0" rtlCol="0" anchor="ctr"/>
+          <a:lstStyle/>
+          <a:p>
+            <a:pPr algn="ctr" indent="0" marL="0">
+              <a:buNone/>
+            </a:pPr>
+            <a:r>
+              <a:rPr lang="en-US" sz="1000" dirty="0">
+                <a:solidFill>
+                  <a:srgbClr val="7E97B8"/>
+                </a:solidFill>
+                <a:latin typeface="Calibri" pitchFamily="34" charset="0"/>
+                <a:ea typeface="Calibri" pitchFamily="34" charset="-122"/>
+                <a:cs typeface="Calibri" pitchFamily="34" charset="-120"/>
+              </a:rPr>
+              <a:t>·</a:t>
+            </a:r>
+            <a:endParaRPr lang="en-US" sz="1000" dirty="0"/>
+          </a:p>
+        </p:txBody>
+      </p:sp>
+      <p:sp>
+        <p:nvSpPr>
+          <p:cNvPr id="32" name="Text 30">
+            <a:hlinkClick r:id="rId2" tooltip=""/>
+          </p:cNvPr>
+          <p:cNvSpPr/>
+          <p:nvPr/>
+        </p:nvSpPr>
+        <p:spPr>
+          <a:xfrm>
+            <a:off x="3374136" y="5943600"/>
+            <a:ext cx="3291840" cy="292608"/>
+          </a:xfrm>
+          <a:prstGeom prst="rect">
+            <a:avLst/>
+          </a:prstGeom>
+          <a:noFill/>
+          <a:ln/>
+        </p:spPr>
+        <p:txBody>
+          <a:bodyPr wrap="square" lIns="0" tIns="0" rIns="0" bIns="0" rtlCol="0" anchor="ctr"/>
+          <a:lstStyle/>
+          <a:p>
+            <a:pPr algn="ctr" indent="0" marL="0">
+              <a:buNone/>
+            </a:pPr>
+            <a:r>
+              <a:rPr lang="en-US" sz="1000" u="sng" dirty="0">
+                <a:solidFill>
+                  <a:srgbClr val="A8C6E8"/>
+                </a:solidFill>
+                <a:latin typeface="Calibri" pitchFamily="34" charset="0"/>
+                <a:ea typeface="Calibri" pitchFamily="34" charset="-122"/>
+                <a:cs typeface="Calibri" pitchFamily="34" charset="-120"/>
+                <a:hlinkClick r:id="rId2" invalidUrl="" action="" tgtFrame="" tooltip="" history="1" highlightClick="0" endSnd="0">
+                  <a:extLst>
+                    <a:ext uri="{A12FA001-AC4F-418D-AE19-62706E023703}">
+                      <ahyp:hlinkClr xmlns:ahyp="http://schemas.microsoft.com/office/drawing/2018/hyperlinkcolor" val="tx"/>
+                    </a:ext>
+                  </a:extLst>
+                </a:hlinkClick>
+              </a:rPr>
+              <a:t>linkedin.com/in/saatwiksairaamvasamsetti</a:t>
+            </a:r>
+            <a:endParaRPr lang="en-US" sz="1000" dirty="0"/>
+          </a:p>
+        </p:txBody>
+      </p:sp>
+      <p:sp>
+        <p:nvSpPr>
+          <p:cNvPr id="33" name="Text 31"/>
+          <p:cNvSpPr/>
+          <p:nvPr/>
+        </p:nvSpPr>
+        <p:spPr>
+          <a:xfrm>
+            <a:off x="6665976" y="5943600"/>
+            <a:ext cx="128016" cy="292608"/>
+          </a:xfrm>
+          <a:prstGeom prst="rect">
+            <a:avLst/>
+          </a:prstGeom>
+          <a:noFill/>
+          <a:ln/>
+        </p:spPr>
+        <p:txBody>
+          <a:bodyPr wrap="square" lIns="0" tIns="0" rIns="0" bIns="0" rtlCol="0" anchor="ctr"/>
+          <a:lstStyle/>
+          <a:p>
+            <a:pPr algn="ctr" indent="0" marL="0">
+              <a:buNone/>
+            </a:pPr>
+            <a:r>
+              <a:rPr lang="en-US" sz="1000" dirty="0">
+                <a:solidFill>
+                  <a:srgbClr val="7E97B8"/>
+                </a:solidFill>
+                <a:latin typeface="Calibri" pitchFamily="34" charset="0"/>
+                <a:ea typeface="Calibri" pitchFamily="34" charset="-122"/>
+                <a:cs typeface="Calibri" pitchFamily="34" charset="-120"/>
+              </a:rPr>
+              <a:t>·</a:t>
+            </a:r>
+            <a:endParaRPr lang="en-US" sz="1000" dirty="0"/>
+          </a:p>
+        </p:txBody>
+      </p:sp>
+      <p:sp>
+        <p:nvSpPr>
+          <p:cNvPr id="34" name="Text 32">
+            <a:hlinkClick r:id="rId3" tooltip=""/>
+          </p:cNvPr>
+          <p:cNvSpPr/>
+          <p:nvPr/>
+        </p:nvSpPr>
+        <p:spPr>
+          <a:xfrm>
+            <a:off x="6793992" y="5943600"/>
+            <a:ext cx="1828800" cy="292608"/>
+          </a:xfrm>
+          <a:prstGeom prst="rect">
+            <a:avLst/>
+          </a:prstGeom>
+          <a:noFill/>
+          <a:ln/>
+        </p:spPr>
+        <p:txBody>
+          <a:bodyPr wrap="square" lIns="0" tIns="0" rIns="0" bIns="0" rtlCol="0" anchor="ctr"/>
+          <a:lstStyle/>
+          <a:p>
+            <a:pPr algn="ctr" indent="0" marL="0">
+              <a:buNone/>
+            </a:pPr>
+            <a:r>
+              <a:rPr lang="en-US" sz="1000" u="sng" dirty="0">
+                <a:solidFill>
+                  <a:srgbClr val="A8C6E8"/>
+                </a:solidFill>
+                <a:latin typeface="Calibri" pitchFamily="34" charset="0"/>
+                <a:ea typeface="Calibri" pitchFamily="34" charset="-122"/>
+                <a:cs typeface="Calibri" pitchFamily="34" charset="-120"/>
+                <a:hlinkClick r:id="rId3" invalidUrl="" action="" tgtFrame="" tooltip="" history="1" highlightClick="0" endSnd="0">
+                  <a:extLst>
+                    <a:ext uri="{A12FA001-AC4F-418D-AE19-62706E023703}">
+                      <ahyp:hlinkClr xmlns:ahyp="http://schemas.microsoft.com/office/drawing/2018/hyperlinkcolor" val="tx"/>
+                    </a:ext>
+                  </a:extLst>
+                </a:hlinkClick>
+              </a:rPr>
+              <a:t>github.com/Nirisha22</a:t>
+            </a:r>
+            <a:endParaRPr lang="en-US" sz="1000" dirty="0"/>
+          </a:p>
+        </p:txBody>
+      </p:sp>
+      <p:sp>
+        <p:nvSpPr>
+          <p:cNvPr id="35" name="Text 33"/>
+          <p:cNvSpPr/>
+          <p:nvPr/>
+        </p:nvSpPr>
+        <p:spPr>
+          <a:xfrm>
+            <a:off x="8622792" y="5943600"/>
+            <a:ext cx="128016" cy="292608"/>
+          </a:xfrm>
+          <a:prstGeom prst="rect">
+            <a:avLst/>
+          </a:prstGeom>
+          <a:noFill/>
+          <a:ln/>
+        </p:spPr>
+        <p:txBody>
+          <a:bodyPr wrap="square" lIns="0" tIns="0" rIns="0" bIns="0" rtlCol="0" anchor="ctr"/>
+          <a:lstStyle/>
+          <a:p>
+            <a:pPr algn="ctr" indent="0" marL="0">
+              <a:buNone/>
+            </a:pPr>
+            <a:r>
+              <a:rPr lang="en-US" sz="1000" dirty="0">
+                <a:solidFill>
+                  <a:srgbClr val="7E97B8"/>
+                </a:solidFill>
+                <a:latin typeface="Calibri" pitchFamily="34" charset="0"/>
+                <a:ea typeface="Calibri" pitchFamily="34" charset="-122"/>
+                <a:cs typeface="Calibri" pitchFamily="34" charset="-120"/>
+              </a:rPr>
+              <a:t>·</a:t>
+            </a:r>
+            <a:endParaRPr lang="en-US" sz="1000" dirty="0"/>
+          </a:p>
+        </p:txBody>
+      </p:sp>
+      <p:sp>
+        <p:nvSpPr>
+          <p:cNvPr id="36" name="Text 34">
+            <a:hlinkClick r:id="rId4" tooltip=""/>
+          </p:cNvPr>
+          <p:cNvSpPr/>
+          <p:nvPr/>
+        </p:nvSpPr>
+        <p:spPr>
+          <a:xfrm>
+            <a:off x="8750808" y="5943600"/>
+            <a:ext cx="2724912" cy="292608"/>
+          </a:xfrm>
+          <a:prstGeom prst="rect">
+            <a:avLst/>
+          </a:prstGeom>
+          <a:noFill/>
+          <a:ln/>
+        </p:spPr>
+        <p:txBody>
+          <a:bodyPr wrap="square" lIns="0" tIns="0" rIns="0" bIns="0" rtlCol="0" anchor="ctr"/>
+          <a:lstStyle/>
+          <a:p>
+            <a:pPr algn="ctr" indent="0" marL="0">
+              <a:buNone/>
+            </a:pPr>
+            <a:r>
+              <a:rPr lang="en-US" sz="1000" u="sng" dirty="0">
+                <a:solidFill>
+                  <a:srgbClr val="A8C6E8"/>
+                </a:solidFill>
+                <a:latin typeface="Calibri" pitchFamily="34" charset="0"/>
+                <a:ea typeface="Calibri" pitchFamily="34" charset="-122"/>
+                <a:cs typeface="Calibri" pitchFamily="34" charset="-120"/>
+                <a:hlinkClick r:id="rId4" invalidUrl="" action="" tgtFrame="" tooltip="" history="1" highlightClick="0" endSnd="0">
+                  <a:extLst>
+                    <a:ext uri="{A12FA001-AC4F-418D-AE19-62706E023703}">
+                      <ahyp:hlinkClr xmlns:ahyp="http://schemas.microsoft.com/office/drawing/2018/hyperlinkcolor" val="tx"/>
+                    </a:ext>
+                  </a:extLst>
+                </a:hlinkClick>
+              </a:rPr>
+              <a:t>linkedin.com/in/nirisha-chowdary</a:t>
+            </a:r>
+            <a:endParaRPr lang="en-US" sz="1000" dirty="0"/>
           </a:p>
         </p:txBody>
       </p:sp>

</xml_diff>